<commit_message>
Verify Circle Agent Wallet settlement on Arc
</commit_message>
<xml_diff>
--- a/artifacts/Safe4_Encode_Arc_Deck.pptx
+++ b/artifacts/Safe4_Encode_Arc_Deck.pptx
@@ -4350,7 +4350,7 @@
                 </a:solidFill>
                 <a:latin typeface="Arial"/>
               </a:rPr>
-              <a:t>286-test regression gate. Real Arc Testnet USDC transaction. Unattended allow/deny demo. Public repository.</a:t>
+              <a:t>293-test regression gate. Fresh Circle Agent Wallet settlement on Arc. Unattended allow/deny demo. Public repository.</a:t>
             </a:r>
           </a:p>
         </p:txBody>
@@ -4500,7 +4500,7 @@
                 </a:solidFill>
                 <a:latin typeface="Arial"/>
               </a:rPr>
-              <a:t>Bind tasks to principals, remove legacy bypasses, deepen onchain receipt verification, and rehearse fresh Circle execution.</a:t>
+              <a:t>Bind tasks to principals, remove legacy bypasses, harden the x402 verifier boundary, and complete security review.</a:t>
             </a:r>
           </a:p>
         </p:txBody>
@@ -8384,7 +8384,7 @@
                 </a:solidFill>
                 <a:latin typeface="Arial"/>
               </a:rPr>
-              <a:t>Execution path uses Arc Testnet; Circle Agent Wallet live mode requires an authenticated testnet session.</a:t>
+              <a:t>Observed Arc Testnet path: Safe4 ALLOW precedes Circle Agent Wallet execution.</a:t>
             </a:r>
           </a:p>
         </p:txBody>
@@ -8454,7 +8454,7 @@
                 </a:solidFill>
                 <a:latin typeface="Arial"/>
               </a:rPr>
-              <a:t>SAFE4 AUTHORIZATION + RPC-VERIFIED REPLAY</a:t>
+              <a:t>SAFE4 AUTHORIZATION + CIRCLE AGENT WALLET</a:t>
             </a:r>
           </a:p>
         </p:txBody>
@@ -8489,7 +8489,7 @@
                 </a:solidFill>
                 <a:latin typeface="Arial"/>
               </a:rPr>
-              <a:t>Optional Circle live execution is coded; authenticated end-to-end validation is pending.</a:t>
+              <a:t>Fresh 0.01 testnet USDC settlement is RPC-verified through the ERC-4337 receipt.</a:t>
             </a:r>
           </a:p>
         </p:txBody>
@@ -9915,7 +9915,7 @@
                 </a:solidFill>
                 <a:latin typeface="Arial"/>
               </a:rPr>
-              <a:t>Arcscan: testnet.arcscan.app/tx/0x24e959…44a7a · verifier: scripts/verify_arc_settlement.py</a:t>
+              <a:t>Arcscan: testnet.arcscan.app/tx/0x648ef1…7752c · ERC-4337 verifier: scripts/verify_arc_settlement.py</a:t>
             </a:r>
           </a:p>
         </p:txBody>
@@ -10560,7 +10560,7 @@
                 </a:solidFill>
                 <a:latin typeface="Consolas"/>
               </a:rPr>
-              <a:t>0x24e9595078de0778428eea09af2a10ec53828c10aca6e4c5517ef1dd09144a7a</a:t>
+              <a:t>0x648ef14e4da7c6bfecce0017d19280ed51fb12635bea94712de926d9f967752c</a:t>
             </a:r>
           </a:p>
         </p:txBody>
@@ -11456,7 +11456,7 @@
                 </a:solidFill>
                 <a:latin typeface="Arial"/>
               </a:rPr>
-              <a:t>Agent Wallets support Arc Testnet. The adapter is coded to attempt Circle execution after ALLOW; authenticated validation is pending.</a:t>
+              <a:t>An authenticated Agent Wallet settled 0.01 testnet USDC after ALLOW. Safe4 verifies its ERC-4337 receipt.</a:t>
             </a:r>
           </a:p>
         </p:txBody>

</xml_diff>

<commit_message>
Align final Circle evidence and deck visibility
</commit_message>
<xml_diff>
--- a/artifacts/Safe4_Encode_Arc_Deck.pptx
+++ b/artifacts/Safe4_Encode_Arc_Deck.pptx
@@ -3093,7 +3093,7 @@
     <p:bg>
       <p:bgPr>
         <a:solidFill>
-          <a:srgbClr val="090B0A"/>
+          <a:srgbClr val="FFFFFF"/>
         </a:solidFill>
         <a:effectLst/>
       </p:bgPr>
@@ -3261,7 +3261,7 @@
           </a:prstGeom>
           <a:ln w="10160">
             <a:solidFill>
-              <a:srgbClr val="313A32"/>
+              <a:srgbClr val="CBD5E1"/>
             </a:solidFill>
           </a:ln>
         </p:spPr>
@@ -3296,7 +3296,7 @@
           </a:prstGeom>
           <a:ln w="10160">
             <a:solidFill>
-              <a:srgbClr val="313A32"/>
+              <a:srgbClr val="CBD5E1"/>
             </a:solidFill>
           </a:ln>
         </p:spPr>
@@ -3341,7 +3341,7 @@
             <a:r>
               <a:rPr sz="1100" b="1">
                 <a:solidFill>
-                  <a:srgbClr val="E8FF3F"/>
+                  <a:srgbClr val="8A5A00"/>
                 </a:solidFill>
                 <a:latin typeface="Arial"/>
               </a:rPr>
@@ -3376,7 +3376,7 @@
             <a:r>
               <a:rPr sz="900" b="0">
                 <a:solidFill>
-                  <a:srgbClr val="99A39A"/>
+                  <a:srgbClr val="4B5563"/>
                 </a:solidFill>
                 <a:latin typeface="Arial"/>
               </a:rPr>
@@ -3411,7 +3411,7 @@
             <a:r>
               <a:rPr sz="1200" b="1">
                 <a:solidFill>
-                  <a:srgbClr val="F4F6F0"/>
+                  <a:srgbClr val="111827"/>
                 </a:solidFill>
                 <a:latin typeface="Arial"/>
               </a:rPr>
@@ -3435,11 +3435,11 @@
             <a:avLst/>
           </a:prstGeom>
           <a:solidFill>
-            <a:srgbClr val="E8FF3F"/>
+            <a:srgbClr val="8A5A00"/>
           </a:solidFill>
           <a:ln w="12700">
             <a:solidFill>
-              <a:srgbClr val="E8FF3F"/>
+              <a:srgbClr val="8A5A00"/>
             </a:solidFill>
           </a:ln>
         </p:spPr>
@@ -3491,7 +3491,7 @@
             <a:r>
               <a:rPr sz="900" b="1">
                 <a:solidFill>
-                  <a:srgbClr val="090B0A"/>
+                  <a:srgbClr val="FFFFFF"/>
                 </a:solidFill>
                 <a:latin typeface="Arial"/>
               </a:rPr>
@@ -3526,7 +3526,7 @@
             <a:r>
               <a:rPr sz="4500" b="1">
                 <a:solidFill>
-                  <a:srgbClr val="F4F6F0"/>
+                  <a:srgbClr val="111827"/>
                 </a:solidFill>
                 <a:latin typeface="Arial"/>
               </a:rPr>
@@ -3563,7 +3563,7 @@
             <a:r>
               <a:rPr sz="1800" b="0">
                 <a:solidFill>
-                  <a:srgbClr val="99A39A"/>
+                  <a:srgbClr val="4B5563"/>
                 </a:solidFill>
                 <a:latin typeface="Arial"/>
               </a:rPr>
@@ -3587,11 +3587,11 @@
             <a:avLst/>
           </a:prstGeom>
           <a:solidFill>
-            <a:srgbClr val="111512"/>
+            <a:srgbClr val="F3F4F6"/>
           </a:solidFill>
           <a:ln w="16510">
             <a:solidFill>
-              <a:srgbClr val="E8FF3F"/>
+              <a:srgbClr val="8A5A00"/>
             </a:solidFill>
           </a:ln>
         </p:spPr>
@@ -3643,7 +3643,7 @@
             <a:r>
               <a:rPr sz="2600" b="1">
                 <a:solidFill>
-                  <a:srgbClr val="E8FF3F"/>
+                  <a:srgbClr val="8A5A00"/>
                 </a:solidFill>
                 <a:latin typeface="Arial"/>
               </a:rPr>
@@ -3678,7 +3678,7 @@
             <a:r>
               <a:rPr sz="7500" b="1">
                 <a:solidFill>
-                  <a:srgbClr val="F4F6F0"/>
+                  <a:srgbClr val="111827"/>
                 </a:solidFill>
                 <a:latin typeface="Arial"/>
               </a:rPr>
@@ -3703,7 +3703,7 @@
           </a:prstGeom>
           <a:ln w="12700">
             <a:solidFill>
-              <a:srgbClr val="E8FF3F"/>
+              <a:srgbClr val="8A5A00"/>
             </a:solidFill>
           </a:ln>
         </p:spPr>
@@ -3748,7 +3748,7 @@
             <a:r>
               <a:rPr sz="1400" b="1">
                 <a:solidFill>
-                  <a:srgbClr val="99A39A"/>
+                  <a:srgbClr val="4B5563"/>
                 </a:solidFill>
                 <a:latin typeface="Arial"/>
               </a:rPr>
@@ -3773,7 +3773,7 @@
     <p:bg>
       <p:bgPr>
         <a:solidFill>
-          <a:srgbClr val="090B0A"/>
+          <a:srgbClr val="FFFFFF"/>
         </a:solidFill>
         <a:effectLst/>
       </p:bgPr>
@@ -3941,7 +3941,7 @@
           </a:prstGeom>
           <a:ln w="10160">
             <a:solidFill>
-              <a:srgbClr val="313A32"/>
+              <a:srgbClr val="CBD5E1"/>
             </a:solidFill>
           </a:ln>
         </p:spPr>
@@ -3976,7 +3976,7 @@
           </a:prstGeom>
           <a:ln w="10160">
             <a:solidFill>
-              <a:srgbClr val="313A32"/>
+              <a:srgbClr val="CBD5E1"/>
             </a:solidFill>
           </a:ln>
         </p:spPr>
@@ -4021,7 +4021,7 @@
             <a:r>
               <a:rPr sz="1100" b="1">
                 <a:solidFill>
-                  <a:srgbClr val="E8FF3F"/>
+                  <a:srgbClr val="8A5A00"/>
                 </a:solidFill>
                 <a:latin typeface="Arial"/>
               </a:rPr>
@@ -4056,7 +4056,7 @@
             <a:r>
               <a:rPr sz="900" b="0">
                 <a:solidFill>
-                  <a:srgbClr val="99A39A"/>
+                  <a:srgbClr val="4B5563"/>
                 </a:solidFill>
                 <a:latin typeface="Arial"/>
               </a:rPr>
@@ -4091,7 +4091,7 @@
             <a:r>
               <a:rPr sz="1200" b="1">
                 <a:solidFill>
-                  <a:srgbClr val="F4F6F0"/>
+                  <a:srgbClr val="111827"/>
                 </a:solidFill>
                 <a:latin typeface="Arial"/>
               </a:rPr>
@@ -4161,7 +4161,7 @@
             <a:r>
               <a:rPr sz="1000" b="1">
                 <a:solidFill>
-                  <a:srgbClr val="E8FF3F"/>
+                  <a:srgbClr val="8A5A00"/>
                 </a:solidFill>
                 <a:latin typeface="Arial"/>
               </a:rPr>
@@ -4196,7 +4196,7 @@
             <a:r>
               <a:rPr sz="3100" b="1">
                 <a:solidFill>
-                  <a:srgbClr val="F4F6F0"/>
+                  <a:srgbClr val="111827"/>
                 </a:solidFill>
                 <a:latin typeface="Arial"/>
               </a:rPr>
@@ -4220,11 +4220,11 @@
             <a:avLst/>
           </a:prstGeom>
           <a:solidFill>
-            <a:srgbClr val="111512"/>
+            <a:srgbClr val="F3F4F6"/>
           </a:solidFill>
           <a:ln w="12700">
             <a:solidFill>
-              <a:srgbClr val="313A32"/>
+              <a:srgbClr val="CBD5E1"/>
             </a:solidFill>
           </a:ln>
         </p:spPr>
@@ -4276,7 +4276,7 @@
             <a:r>
               <a:rPr sz="900" b="1">
                 <a:solidFill>
-                  <a:srgbClr val="70F6A5"/>
+                  <a:srgbClr val="047857"/>
                 </a:solidFill>
                 <a:latin typeface="Arial"/>
               </a:rPr>
@@ -4311,7 +4311,7 @@
             <a:r>
               <a:rPr sz="2000" b="1">
                 <a:solidFill>
-                  <a:srgbClr val="F4F6F0"/>
+                  <a:srgbClr val="111827"/>
                 </a:solidFill>
                 <a:latin typeface="Arial"/>
               </a:rPr>
@@ -4346,7 +4346,7 @@
             <a:r>
               <a:rPr sz="1200" b="0">
                 <a:solidFill>
-                  <a:srgbClr val="99A39A"/>
+                  <a:srgbClr val="4B5563"/>
                 </a:solidFill>
                 <a:latin typeface="Arial"/>
               </a:rPr>
@@ -4370,11 +4370,11 @@
             <a:avLst/>
           </a:prstGeom>
           <a:solidFill>
-            <a:srgbClr val="111512"/>
+            <a:srgbClr val="F3F4F6"/>
           </a:solidFill>
           <a:ln w="12700">
             <a:solidFill>
-              <a:srgbClr val="313A32"/>
+              <a:srgbClr val="CBD5E1"/>
             </a:solidFill>
           </a:ln>
         </p:spPr>
@@ -4426,7 +4426,7 @@
             <a:r>
               <a:rPr sz="900" b="1">
                 <a:solidFill>
-                  <a:srgbClr val="E8FF3F"/>
+                  <a:srgbClr val="8A5A00"/>
                 </a:solidFill>
                 <a:latin typeface="Arial"/>
               </a:rPr>
@@ -4461,7 +4461,7 @@
             <a:r>
               <a:rPr sz="2000" b="1">
                 <a:solidFill>
-                  <a:srgbClr val="F4F6F0"/>
+                  <a:srgbClr val="111827"/>
                 </a:solidFill>
                 <a:latin typeface="Arial"/>
               </a:rPr>
@@ -4496,7 +4496,7 @@
             <a:r>
               <a:rPr sz="1200" b="0">
                 <a:solidFill>
-                  <a:srgbClr val="99A39A"/>
+                  <a:srgbClr val="4B5563"/>
                 </a:solidFill>
                 <a:latin typeface="Arial"/>
               </a:rPr>
@@ -4520,11 +4520,11 @@
             <a:avLst/>
           </a:prstGeom>
           <a:solidFill>
-            <a:srgbClr val="111512"/>
+            <a:srgbClr val="F3F4F6"/>
           </a:solidFill>
           <a:ln w="12700">
             <a:solidFill>
-              <a:srgbClr val="313A32"/>
+              <a:srgbClr val="CBD5E1"/>
             </a:solidFill>
           </a:ln>
         </p:spPr>
@@ -4576,7 +4576,7 @@
             <a:r>
               <a:rPr sz="900" b="1">
                 <a:solidFill>
-                  <a:srgbClr val="7FE8FF"/>
+                  <a:srgbClr val="075985"/>
                 </a:solidFill>
                 <a:latin typeface="Arial"/>
               </a:rPr>
@@ -4611,7 +4611,7 @@
             <a:r>
               <a:rPr sz="2000" b="1">
                 <a:solidFill>
-                  <a:srgbClr val="F4F6F0"/>
+                  <a:srgbClr val="111827"/>
                 </a:solidFill>
                 <a:latin typeface="Arial"/>
               </a:rPr>
@@ -4646,7 +4646,7 @@
             <a:r>
               <a:rPr sz="1200" b="0">
                 <a:solidFill>
-                  <a:srgbClr val="99A39A"/>
+                  <a:srgbClr val="4B5563"/>
                 </a:solidFill>
                 <a:latin typeface="Arial"/>
               </a:rPr>
@@ -4681,7 +4681,7 @@
             <a:r>
               <a:rPr sz="900" b="1">
                 <a:solidFill>
-                  <a:srgbClr val="E8FF3F"/>
+                  <a:srgbClr val="8A5A00"/>
                 </a:solidFill>
                 <a:latin typeface="Arial"/>
               </a:rPr>
@@ -4716,7 +4716,7 @@
             <a:r>
               <a:rPr sz="1500" b="1">
                 <a:solidFill>
-                  <a:srgbClr val="F4F6F0"/>
+                  <a:srgbClr val="111827"/>
                 </a:solidFill>
                 <a:latin typeface="Arial"/>
               </a:rPr>
@@ -4739,7 +4739,7 @@
     <p:bg>
       <p:bgPr>
         <a:solidFill>
-          <a:srgbClr val="090B0A"/>
+          <a:srgbClr val="FFFFFF"/>
         </a:solidFill>
         <a:effectLst/>
       </p:bgPr>
@@ -4907,7 +4907,7 @@
           </a:prstGeom>
           <a:ln w="10160">
             <a:solidFill>
-              <a:srgbClr val="313A32"/>
+              <a:srgbClr val="CBD5E1"/>
             </a:solidFill>
           </a:ln>
         </p:spPr>
@@ -4942,7 +4942,7 @@
           </a:prstGeom>
           <a:ln w="10160">
             <a:solidFill>
-              <a:srgbClr val="313A32"/>
+              <a:srgbClr val="CBD5E1"/>
             </a:solidFill>
           </a:ln>
         </p:spPr>
@@ -4987,7 +4987,7 @@
             <a:r>
               <a:rPr sz="1100" b="1">
                 <a:solidFill>
-                  <a:srgbClr val="E8FF3F"/>
+                  <a:srgbClr val="8A5A00"/>
                 </a:solidFill>
                 <a:latin typeface="Arial"/>
               </a:rPr>
@@ -5022,7 +5022,7 @@
             <a:r>
               <a:rPr sz="900" b="0">
                 <a:solidFill>
-                  <a:srgbClr val="99A39A"/>
+                  <a:srgbClr val="4B5563"/>
                 </a:solidFill>
                 <a:latin typeface="Arial"/>
               </a:rPr>
@@ -5057,7 +5057,7 @@
             <a:r>
               <a:rPr sz="1200" b="1">
                 <a:solidFill>
-                  <a:srgbClr val="F4F6F0"/>
+                  <a:srgbClr val="111827"/>
                 </a:solidFill>
                 <a:latin typeface="Arial"/>
               </a:rPr>
@@ -5092,7 +5092,7 @@
             <a:r>
               <a:rPr sz="1000" b="1">
                 <a:solidFill>
-                  <a:srgbClr val="E8FF3F"/>
+                  <a:srgbClr val="8A5A00"/>
                 </a:solidFill>
                 <a:latin typeface="Arial"/>
               </a:rPr>
@@ -5127,7 +5127,7 @@
             <a:r>
               <a:rPr sz="3100" b="1">
                 <a:solidFill>
-                  <a:srgbClr val="F4F6F0"/>
+                  <a:srgbClr val="111827"/>
                 </a:solidFill>
                 <a:latin typeface="Arial"/>
               </a:rPr>
@@ -5162,7 +5162,7 @@
             <a:r>
               <a:rPr sz="1400" b="0">
                 <a:solidFill>
-                  <a:srgbClr val="99A39A"/>
+                  <a:srgbClr val="4B5563"/>
                 </a:solidFill>
                 <a:latin typeface="Arial"/>
               </a:rPr>
@@ -5186,11 +5186,11 @@
             <a:avLst/>
           </a:prstGeom>
           <a:solidFill>
-            <a:srgbClr val="111512"/>
+            <a:srgbClr val="F3F4F6"/>
           </a:solidFill>
           <a:ln w="12700">
             <a:solidFill>
-              <a:srgbClr val="313A32"/>
+              <a:srgbClr val="CBD5E1"/>
             </a:solidFill>
           </a:ln>
         </p:spPr>
@@ -5242,7 +5242,7 @@
             <a:r>
               <a:rPr sz="900" b="1">
                 <a:solidFill>
-                  <a:srgbClr val="7FE8FF"/>
+                  <a:srgbClr val="075985"/>
                 </a:solidFill>
                 <a:latin typeface="Arial"/>
               </a:rPr>
@@ -5277,7 +5277,7 @@
             <a:r>
               <a:rPr sz="2000" b="1">
                 <a:solidFill>
-                  <a:srgbClr val="F4F6F0"/>
+                  <a:srgbClr val="111827"/>
                 </a:solidFill>
                 <a:latin typeface="Arial"/>
               </a:rPr>
@@ -5312,7 +5312,7 @@
             <a:r>
               <a:rPr sz="1200" b="0">
                 <a:solidFill>
-                  <a:srgbClr val="99A39A"/>
+                  <a:srgbClr val="4B5563"/>
                 </a:solidFill>
                 <a:latin typeface="Arial"/>
               </a:rPr>
@@ -5336,11 +5336,11 @@
             <a:avLst/>
           </a:prstGeom>
           <a:solidFill>
-            <a:srgbClr val="111512"/>
+            <a:srgbClr val="F3F4F6"/>
           </a:solidFill>
           <a:ln w="12700">
             <a:solidFill>
-              <a:srgbClr val="313A32"/>
+              <a:srgbClr val="CBD5E1"/>
             </a:solidFill>
           </a:ln>
         </p:spPr>
@@ -5392,7 +5392,7 @@
             <a:r>
               <a:rPr sz="900" b="1">
                 <a:solidFill>
-                  <a:srgbClr val="FF7A68"/>
+                  <a:srgbClr val="B91C1C"/>
                 </a:solidFill>
                 <a:latin typeface="Arial"/>
               </a:rPr>
@@ -5427,7 +5427,7 @@
             <a:r>
               <a:rPr sz="2000" b="1">
                 <a:solidFill>
-                  <a:srgbClr val="F4F6F0"/>
+                  <a:srgbClr val="111827"/>
                 </a:solidFill>
                 <a:latin typeface="Arial"/>
               </a:rPr>
@@ -5462,7 +5462,7 @@
             <a:r>
               <a:rPr sz="1200" b="0">
                 <a:solidFill>
-                  <a:srgbClr val="99A39A"/>
+                  <a:srgbClr val="4B5563"/>
                 </a:solidFill>
                 <a:latin typeface="Arial"/>
               </a:rPr>
@@ -5486,11 +5486,11 @@
             <a:avLst/>
           </a:prstGeom>
           <a:solidFill>
-            <a:srgbClr val="111512"/>
+            <a:srgbClr val="F3F4F6"/>
           </a:solidFill>
           <a:ln w="12700">
             <a:solidFill>
-              <a:srgbClr val="313A32"/>
+              <a:srgbClr val="CBD5E1"/>
             </a:solidFill>
           </a:ln>
         </p:spPr>
@@ -5542,7 +5542,7 @@
             <a:r>
               <a:rPr sz="900" b="1">
                 <a:solidFill>
-                  <a:srgbClr val="E8FF3F"/>
+                  <a:srgbClr val="8A5A00"/>
                 </a:solidFill>
                 <a:latin typeface="Arial"/>
               </a:rPr>
@@ -5577,7 +5577,7 @@
             <a:r>
               <a:rPr sz="2000" b="1">
                 <a:solidFill>
-                  <a:srgbClr val="F4F6F0"/>
+                  <a:srgbClr val="111827"/>
                 </a:solidFill>
                 <a:latin typeface="Arial"/>
               </a:rPr>
@@ -5612,7 +5612,7 @@
             <a:r>
               <a:rPr sz="1200" b="0">
                 <a:solidFill>
-                  <a:srgbClr val="99A39A"/>
+                  <a:srgbClr val="4B5563"/>
                 </a:solidFill>
                 <a:latin typeface="Arial"/>
               </a:rPr>
@@ -5637,7 +5637,7 @@
           </a:prstGeom>
           <a:ln w="25400">
             <a:solidFill>
-              <a:srgbClr val="7FE8FF"/>
+              <a:srgbClr val="075985"/>
             </a:solidFill>
           </a:ln>
         </p:spPr>
@@ -5672,7 +5672,7 @@
           </a:prstGeom>
           <a:ln w="25400">
             <a:solidFill>
-              <a:srgbClr val="E8FF3F"/>
+              <a:srgbClr val="8A5A00"/>
             </a:solidFill>
           </a:ln>
         </p:spPr>
@@ -5717,7 +5717,7 @@
             <a:r>
               <a:rPr sz="1100" b="1">
                 <a:solidFill>
-                  <a:srgbClr val="E8FF3F"/>
+                  <a:srgbClr val="8A5A00"/>
                 </a:solidFill>
                 <a:latin typeface="Arial"/>
               </a:rPr>
@@ -5740,7 +5740,7 @@
     <p:bg>
       <p:bgPr>
         <a:solidFill>
-          <a:srgbClr val="090B0A"/>
+          <a:srgbClr val="FFFFFF"/>
         </a:solidFill>
         <a:effectLst/>
       </p:bgPr>
@@ -5908,7 +5908,7 @@
           </a:prstGeom>
           <a:ln w="10160">
             <a:solidFill>
-              <a:srgbClr val="313A32"/>
+              <a:srgbClr val="CBD5E1"/>
             </a:solidFill>
           </a:ln>
         </p:spPr>
@@ -5943,7 +5943,7 @@
           </a:prstGeom>
           <a:ln w="10160">
             <a:solidFill>
-              <a:srgbClr val="313A32"/>
+              <a:srgbClr val="CBD5E1"/>
             </a:solidFill>
           </a:ln>
         </p:spPr>
@@ -5988,7 +5988,7 @@
             <a:r>
               <a:rPr sz="1100" b="1">
                 <a:solidFill>
-                  <a:srgbClr val="E8FF3F"/>
+                  <a:srgbClr val="8A5A00"/>
                 </a:solidFill>
                 <a:latin typeface="Arial"/>
               </a:rPr>
@@ -6023,7 +6023,7 @@
             <a:r>
               <a:rPr sz="900" b="0">
                 <a:solidFill>
-                  <a:srgbClr val="99A39A"/>
+                  <a:srgbClr val="4B5563"/>
                 </a:solidFill>
                 <a:latin typeface="Arial"/>
               </a:rPr>
@@ -6058,7 +6058,7 @@
             <a:r>
               <a:rPr sz="1200" b="1">
                 <a:solidFill>
-                  <a:srgbClr val="F4F6F0"/>
+                  <a:srgbClr val="111827"/>
                 </a:solidFill>
                 <a:latin typeface="Arial"/>
               </a:rPr>
@@ -6128,7 +6128,7 @@
             <a:r>
               <a:rPr sz="1000" b="1">
                 <a:solidFill>
-                  <a:srgbClr val="E8FF3F"/>
+                  <a:srgbClr val="8A5A00"/>
                 </a:solidFill>
                 <a:latin typeface="Arial"/>
               </a:rPr>
@@ -6163,7 +6163,7 @@
             <a:r>
               <a:rPr sz="3100" b="1">
                 <a:solidFill>
-                  <a:srgbClr val="F4F6F0"/>
+                  <a:srgbClr val="111827"/>
                 </a:solidFill>
                 <a:latin typeface="Arial"/>
               </a:rPr>
@@ -6198,7 +6198,7 @@
             <a:r>
               <a:rPr sz="1400" b="0">
                 <a:solidFill>
-                  <a:srgbClr val="99A39A"/>
+                  <a:srgbClr val="4B5563"/>
                 </a:solidFill>
                 <a:latin typeface="Arial"/>
               </a:rPr>
@@ -6222,11 +6222,11 @@
             <a:avLst/>
           </a:prstGeom>
           <a:solidFill>
-            <a:srgbClr val="111512"/>
+            <a:srgbClr val="F3F4F6"/>
           </a:solidFill>
           <a:ln w="12700">
             <a:solidFill>
-              <a:srgbClr val="313A32"/>
+              <a:srgbClr val="CBD5E1"/>
             </a:solidFill>
           </a:ln>
         </p:spPr>
@@ -6278,7 +6278,7 @@
             <a:r>
               <a:rPr sz="2400" b="1">
                 <a:solidFill>
-                  <a:srgbClr val="7FE8FF"/>
+                  <a:srgbClr val="075985"/>
                 </a:solidFill>
                 <a:latin typeface="Arial"/>
               </a:rPr>
@@ -6313,7 +6313,7 @@
             <a:r>
               <a:rPr sz="900" b="0">
                 <a:solidFill>
-                  <a:srgbClr val="99A39A"/>
+                  <a:srgbClr val="4B5563"/>
                 </a:solidFill>
                 <a:latin typeface="Arial"/>
               </a:rPr>
@@ -6337,11 +6337,11 @@
             <a:avLst/>
           </a:prstGeom>
           <a:solidFill>
-            <a:srgbClr val="111512"/>
+            <a:srgbClr val="F3F4F6"/>
           </a:solidFill>
           <a:ln w="12700">
             <a:solidFill>
-              <a:srgbClr val="313A32"/>
+              <a:srgbClr val="CBD5E1"/>
             </a:solidFill>
           </a:ln>
         </p:spPr>
@@ -6393,7 +6393,7 @@
             <a:r>
               <a:rPr sz="2400" b="1">
                 <a:solidFill>
-                  <a:srgbClr val="E8FF3F"/>
+                  <a:srgbClr val="8A5A00"/>
                 </a:solidFill>
                 <a:latin typeface="Arial"/>
               </a:rPr>
@@ -6428,7 +6428,7 @@
             <a:r>
               <a:rPr sz="900" b="0">
                 <a:solidFill>
-                  <a:srgbClr val="99A39A"/>
+                  <a:srgbClr val="4B5563"/>
                 </a:solidFill>
                 <a:latin typeface="Arial"/>
               </a:rPr>
@@ -6452,11 +6452,11 @@
             <a:avLst/>
           </a:prstGeom>
           <a:solidFill>
-            <a:srgbClr val="111512"/>
+            <a:srgbClr val="F3F4F6"/>
           </a:solidFill>
           <a:ln w="12700">
             <a:solidFill>
-              <a:srgbClr val="313A32"/>
+              <a:srgbClr val="CBD5E1"/>
             </a:solidFill>
           </a:ln>
         </p:spPr>
@@ -6508,7 +6508,7 @@
             <a:r>
               <a:rPr sz="2400" b="1">
                 <a:solidFill>
-                  <a:srgbClr val="70F6A5"/>
+                  <a:srgbClr val="047857"/>
                 </a:solidFill>
                 <a:latin typeface="Arial"/>
               </a:rPr>
@@ -6543,7 +6543,7 @@
             <a:r>
               <a:rPr sz="900" b="0">
                 <a:solidFill>
-                  <a:srgbClr val="99A39A"/>
+                  <a:srgbClr val="4B5563"/>
                 </a:solidFill>
                 <a:latin typeface="Arial"/>
               </a:rPr>
@@ -6567,11 +6567,11 @@
             <a:avLst/>
           </a:prstGeom>
           <a:solidFill>
-            <a:srgbClr val="171C18"/>
+            <a:srgbClr val="E5E7EB"/>
           </a:solidFill>
           <a:ln w="12700">
             <a:solidFill>
-              <a:srgbClr val="E8FF3F"/>
+              <a:srgbClr val="8A5A00"/>
             </a:solidFill>
           </a:ln>
         </p:spPr>
@@ -6623,7 +6623,7 @@
             <a:r>
               <a:rPr sz="1800" b="1">
                 <a:solidFill>
-                  <a:srgbClr val="F4F6F0"/>
+                  <a:srgbClr val="111827"/>
                 </a:solidFill>
                 <a:latin typeface="Arial"/>
               </a:rPr>
@@ -6658,7 +6658,7 @@
             <a:r>
               <a:rPr sz="1800" b="1">
                 <a:solidFill>
-                  <a:srgbClr val="E8FF3F"/>
+                  <a:srgbClr val="8A5A00"/>
                 </a:solidFill>
                 <a:latin typeface="Arial"/>
               </a:rPr>
@@ -6681,7 +6681,7 @@
     <p:bg>
       <p:bgPr>
         <a:solidFill>
-          <a:srgbClr val="090B0A"/>
+          <a:srgbClr val="FFFFFF"/>
         </a:solidFill>
         <a:effectLst/>
       </p:bgPr>
@@ -6849,7 +6849,7 @@
           </a:prstGeom>
           <a:ln w="10160">
             <a:solidFill>
-              <a:srgbClr val="313A32"/>
+              <a:srgbClr val="CBD5E1"/>
             </a:solidFill>
           </a:ln>
         </p:spPr>
@@ -6884,7 +6884,7 @@
           </a:prstGeom>
           <a:ln w="10160">
             <a:solidFill>
-              <a:srgbClr val="313A32"/>
+              <a:srgbClr val="CBD5E1"/>
             </a:solidFill>
           </a:ln>
         </p:spPr>
@@ -6929,7 +6929,7 @@
             <a:r>
               <a:rPr sz="1100" b="1">
                 <a:solidFill>
-                  <a:srgbClr val="E8FF3F"/>
+                  <a:srgbClr val="8A5A00"/>
                 </a:solidFill>
                 <a:latin typeface="Arial"/>
               </a:rPr>
@@ -6964,7 +6964,7 @@
             <a:r>
               <a:rPr sz="900" b="0">
                 <a:solidFill>
-                  <a:srgbClr val="99A39A"/>
+                  <a:srgbClr val="4B5563"/>
                 </a:solidFill>
                 <a:latin typeface="Arial"/>
               </a:rPr>
@@ -6999,7 +6999,7 @@
             <a:r>
               <a:rPr sz="1200" b="1">
                 <a:solidFill>
-                  <a:srgbClr val="F4F6F0"/>
+                  <a:srgbClr val="111827"/>
                 </a:solidFill>
                 <a:latin typeface="Arial"/>
               </a:rPr>
@@ -7034,7 +7034,7 @@
             <a:r>
               <a:rPr sz="1000" b="1">
                 <a:solidFill>
-                  <a:srgbClr val="E8FF3F"/>
+                  <a:srgbClr val="8A5A00"/>
                 </a:solidFill>
                 <a:latin typeface="Arial"/>
               </a:rPr>
@@ -7069,7 +7069,7 @@
             <a:r>
               <a:rPr sz="3100" b="1">
                 <a:solidFill>
-                  <a:srgbClr val="F4F6F0"/>
+                  <a:srgbClr val="111827"/>
                 </a:solidFill>
                 <a:latin typeface="Arial"/>
               </a:rPr>
@@ -7104,7 +7104,7 @@
             <a:r>
               <a:rPr sz="1400" b="0">
                 <a:solidFill>
-                  <a:srgbClr val="99A39A"/>
+                  <a:srgbClr val="4B5563"/>
                 </a:solidFill>
                 <a:latin typeface="Arial"/>
               </a:rPr>
@@ -7128,11 +7128,11 @@
             <a:avLst/>
           </a:prstGeom>
           <a:solidFill>
-            <a:srgbClr val="111512"/>
+            <a:srgbClr val="F3F4F6"/>
           </a:solidFill>
           <a:ln w="12700">
             <a:solidFill>
-              <a:srgbClr val="313A32"/>
+              <a:srgbClr val="CBD5E1"/>
             </a:solidFill>
           </a:ln>
         </p:spPr>
@@ -7184,7 +7184,7 @@
             <a:r>
               <a:rPr sz="900" b="1">
                 <a:solidFill>
-                  <a:srgbClr val="E8FF3F"/>
+                  <a:srgbClr val="8A5A00"/>
                 </a:solidFill>
                 <a:latin typeface="Arial"/>
               </a:rPr>
@@ -7219,7 +7219,7 @@
             <a:r>
               <a:rPr sz="1300" b="1">
                 <a:solidFill>
-                  <a:srgbClr val="F4F6F0"/>
+                  <a:srgbClr val="111827"/>
                 </a:solidFill>
                 <a:latin typeface="Arial"/>
               </a:rPr>
@@ -7254,7 +7254,7 @@
             <a:r>
               <a:rPr sz="1050" b="0">
                 <a:solidFill>
-                  <a:srgbClr val="99A39A"/>
+                  <a:srgbClr val="4B5563"/>
                 </a:solidFill>
                 <a:latin typeface="Arial"/>
               </a:rPr>
@@ -7278,11 +7278,11 @@
             <a:avLst/>
           </a:prstGeom>
           <a:solidFill>
-            <a:srgbClr val="111512"/>
+            <a:srgbClr val="F3F4F6"/>
           </a:solidFill>
           <a:ln w="12700">
             <a:solidFill>
-              <a:srgbClr val="313A32"/>
+              <a:srgbClr val="CBD5E1"/>
             </a:solidFill>
           </a:ln>
         </p:spPr>
@@ -7334,7 +7334,7 @@
             <a:r>
               <a:rPr sz="900" b="1">
                 <a:solidFill>
-                  <a:srgbClr val="70F6A5"/>
+                  <a:srgbClr val="047857"/>
                 </a:solidFill>
                 <a:latin typeface="Arial"/>
               </a:rPr>
@@ -7369,7 +7369,7 @@
             <a:r>
               <a:rPr sz="1300" b="1">
                 <a:solidFill>
-                  <a:srgbClr val="F4F6F0"/>
+                  <a:srgbClr val="111827"/>
                 </a:solidFill>
                 <a:latin typeface="Arial"/>
               </a:rPr>
@@ -7404,7 +7404,7 @@
             <a:r>
               <a:rPr sz="1050" b="0">
                 <a:solidFill>
-                  <a:srgbClr val="99A39A"/>
+                  <a:srgbClr val="4B5563"/>
                 </a:solidFill>
                 <a:latin typeface="Arial"/>
               </a:rPr>
@@ -7428,11 +7428,11 @@
             <a:avLst/>
           </a:prstGeom>
           <a:solidFill>
-            <a:srgbClr val="111512"/>
+            <a:srgbClr val="F3F4F6"/>
           </a:solidFill>
           <a:ln w="12700">
             <a:solidFill>
-              <a:srgbClr val="313A32"/>
+              <a:srgbClr val="CBD5E1"/>
             </a:solidFill>
           </a:ln>
         </p:spPr>
@@ -7484,7 +7484,7 @@
             <a:r>
               <a:rPr sz="900" b="1">
                 <a:solidFill>
-                  <a:srgbClr val="7FE8FF"/>
+                  <a:srgbClr val="075985"/>
                 </a:solidFill>
                 <a:latin typeface="Arial"/>
               </a:rPr>
@@ -7519,7 +7519,7 @@
             <a:r>
               <a:rPr sz="1300" b="1">
                 <a:solidFill>
-                  <a:srgbClr val="F4F6F0"/>
+                  <a:srgbClr val="111827"/>
                 </a:solidFill>
                 <a:latin typeface="Arial"/>
               </a:rPr>
@@ -7554,7 +7554,7 @@
             <a:r>
               <a:rPr sz="1050" b="0">
                 <a:solidFill>
-                  <a:srgbClr val="99A39A"/>
+                  <a:srgbClr val="4B5563"/>
                 </a:solidFill>
                 <a:latin typeface="Arial"/>
               </a:rPr>
@@ -7578,11 +7578,11 @@
             <a:avLst/>
           </a:prstGeom>
           <a:solidFill>
-            <a:srgbClr val="111512"/>
+            <a:srgbClr val="F3F4F6"/>
           </a:solidFill>
           <a:ln w="12700">
             <a:solidFill>
-              <a:srgbClr val="313A32"/>
+              <a:srgbClr val="CBD5E1"/>
             </a:solidFill>
           </a:ln>
         </p:spPr>
@@ -7634,7 +7634,7 @@
             <a:r>
               <a:rPr sz="900" b="1">
                 <a:solidFill>
-                  <a:srgbClr val="F4F6F0"/>
+                  <a:srgbClr val="111827"/>
                 </a:solidFill>
                 <a:latin typeface="Arial"/>
               </a:rPr>
@@ -7669,7 +7669,7 @@
             <a:r>
               <a:rPr sz="1300" b="1">
                 <a:solidFill>
-                  <a:srgbClr val="F4F6F0"/>
+                  <a:srgbClr val="111827"/>
                 </a:solidFill>
                 <a:latin typeface="Arial"/>
               </a:rPr>
@@ -7704,7 +7704,7 @@
             <a:r>
               <a:rPr sz="1050" b="0">
                 <a:solidFill>
-                  <a:srgbClr val="99A39A"/>
+                  <a:srgbClr val="4B5563"/>
                 </a:solidFill>
                 <a:latin typeface="Arial"/>
               </a:rPr>
@@ -7728,11 +7728,11 @@
             <a:avLst/>
           </a:prstGeom>
           <a:solidFill>
-            <a:srgbClr val="111512"/>
+            <a:srgbClr val="F3F4F6"/>
           </a:solidFill>
           <a:ln w="12700">
             <a:solidFill>
-              <a:srgbClr val="313A32"/>
+              <a:srgbClr val="CBD5E1"/>
             </a:solidFill>
           </a:ln>
         </p:spPr>
@@ -7784,7 +7784,7 @@
             <a:r>
               <a:rPr sz="900" b="1">
                 <a:solidFill>
-                  <a:srgbClr val="E8FF3F"/>
+                  <a:srgbClr val="8A5A00"/>
                 </a:solidFill>
                 <a:latin typeface="Arial"/>
               </a:rPr>
@@ -7819,7 +7819,7 @@
             <a:r>
               <a:rPr sz="1300" b="1">
                 <a:solidFill>
-                  <a:srgbClr val="F4F6F0"/>
+                  <a:srgbClr val="111827"/>
                 </a:solidFill>
                 <a:latin typeface="Arial"/>
               </a:rPr>
@@ -7854,7 +7854,7 @@
             <a:r>
               <a:rPr sz="1050" b="0">
                 <a:solidFill>
-                  <a:srgbClr val="99A39A"/>
+                  <a:srgbClr val="4B5563"/>
                 </a:solidFill>
                 <a:latin typeface="Arial"/>
               </a:rPr>
@@ -7878,11 +7878,11 @@
             <a:avLst/>
           </a:prstGeom>
           <a:solidFill>
-            <a:srgbClr val="111512"/>
+            <a:srgbClr val="F3F4F6"/>
           </a:solidFill>
           <a:ln w="12700">
             <a:solidFill>
-              <a:srgbClr val="313A32"/>
+              <a:srgbClr val="CBD5E1"/>
             </a:solidFill>
           </a:ln>
         </p:spPr>
@@ -7934,7 +7934,7 @@
             <a:r>
               <a:rPr sz="900" b="1">
                 <a:solidFill>
-                  <a:srgbClr val="70F6A5"/>
+                  <a:srgbClr val="047857"/>
                 </a:solidFill>
                 <a:latin typeface="Arial"/>
               </a:rPr>
@@ -7969,7 +7969,7 @@
             <a:r>
               <a:rPr sz="1300" b="1">
                 <a:solidFill>
-                  <a:srgbClr val="F4F6F0"/>
+                  <a:srgbClr val="111827"/>
                 </a:solidFill>
                 <a:latin typeface="Arial"/>
               </a:rPr>
@@ -8004,7 +8004,7 @@
             <a:r>
               <a:rPr sz="1050" b="0">
                 <a:solidFill>
-                  <a:srgbClr val="99A39A"/>
+                  <a:srgbClr val="4B5563"/>
                 </a:solidFill>
                 <a:latin typeface="Arial"/>
               </a:rPr>
@@ -8027,7 +8027,7 @@
     <p:bg>
       <p:bgPr>
         <a:solidFill>
-          <a:srgbClr val="090B0A"/>
+          <a:srgbClr val="FFFFFF"/>
         </a:solidFill>
         <a:effectLst/>
       </p:bgPr>
@@ -8195,7 +8195,7 @@
           </a:prstGeom>
           <a:ln w="10160">
             <a:solidFill>
-              <a:srgbClr val="313A32"/>
+              <a:srgbClr val="CBD5E1"/>
             </a:solidFill>
           </a:ln>
         </p:spPr>
@@ -8230,7 +8230,7 @@
           </a:prstGeom>
           <a:ln w="10160">
             <a:solidFill>
-              <a:srgbClr val="313A32"/>
+              <a:srgbClr val="CBD5E1"/>
             </a:solidFill>
           </a:ln>
         </p:spPr>
@@ -8275,7 +8275,7 @@
             <a:r>
               <a:rPr sz="1100" b="1">
                 <a:solidFill>
-                  <a:srgbClr val="E8FF3F"/>
+                  <a:srgbClr val="8A5A00"/>
                 </a:solidFill>
                 <a:latin typeface="Arial"/>
               </a:rPr>
@@ -8310,7 +8310,7 @@
             <a:r>
               <a:rPr sz="900" b="0">
                 <a:solidFill>
-                  <a:srgbClr val="99A39A"/>
+                  <a:srgbClr val="4B5563"/>
                 </a:solidFill>
                 <a:latin typeface="Arial"/>
               </a:rPr>
@@ -8345,7 +8345,7 @@
             <a:r>
               <a:rPr sz="1200" b="1">
                 <a:solidFill>
-                  <a:srgbClr val="F4F6F0"/>
+                  <a:srgbClr val="111827"/>
                 </a:solidFill>
                 <a:latin typeface="Arial"/>
               </a:rPr>
@@ -8415,7 +8415,7 @@
             <a:r>
               <a:rPr sz="1000" b="1">
                 <a:solidFill>
-                  <a:srgbClr val="E8FF3F"/>
+                  <a:srgbClr val="8A5A00"/>
                 </a:solidFill>
                 <a:latin typeface="Arial"/>
               </a:rPr>
@@ -8450,7 +8450,7 @@
             <a:r>
               <a:rPr sz="3100" b="1">
                 <a:solidFill>
-                  <a:srgbClr val="F4F6F0"/>
+                  <a:srgbClr val="111827"/>
                 </a:solidFill>
                 <a:latin typeface="Arial"/>
               </a:rPr>
@@ -8485,7 +8485,7 @@
             <a:r>
               <a:rPr sz="1400" b="0">
                 <a:solidFill>
-                  <a:srgbClr val="99A39A"/>
+                  <a:srgbClr val="4B5563"/>
                 </a:solidFill>
                 <a:latin typeface="Arial"/>
               </a:rPr>
@@ -8509,11 +8509,11 @@
             <a:avLst/>
           </a:prstGeom>
           <a:solidFill>
-            <a:srgbClr val="111512"/>
+            <a:srgbClr val="F3F4F6"/>
           </a:solidFill>
           <a:ln w="12700">
             <a:solidFill>
-              <a:srgbClr val="313A32"/>
+              <a:srgbClr val="CBD5E1"/>
             </a:solidFill>
           </a:ln>
         </p:spPr>
@@ -8565,7 +8565,7 @@
             <a:r>
               <a:rPr sz="900" b="1">
                 <a:solidFill>
-                  <a:srgbClr val="E8FF3F"/>
+                  <a:srgbClr val="8A5A00"/>
                 </a:solidFill>
                 <a:latin typeface="Arial"/>
               </a:rPr>
@@ -8600,7 +8600,7 @@
             <a:r>
               <a:rPr sz="1300" b="1">
                 <a:solidFill>
-                  <a:srgbClr val="F4F6F0"/>
+                  <a:srgbClr val="111827"/>
                 </a:solidFill>
                 <a:latin typeface="Arial"/>
               </a:rPr>
@@ -8635,7 +8635,7 @@
             <a:r>
               <a:rPr sz="850" b="0">
                 <a:solidFill>
-                  <a:srgbClr val="99A39A"/>
+                  <a:srgbClr val="4B5563"/>
                 </a:solidFill>
                 <a:latin typeface="Arial"/>
               </a:rPr>
@@ -8660,7 +8660,7 @@
           </a:prstGeom>
           <a:ln w="22860">
             <a:solidFill>
-              <a:srgbClr val="E8FF3F"/>
+              <a:srgbClr val="8A5A00"/>
             </a:solidFill>
           </a:ln>
         </p:spPr>
@@ -8694,11 +8694,11 @@
             <a:avLst/>
           </a:prstGeom>
           <a:solidFill>
-            <a:srgbClr val="111512"/>
+            <a:srgbClr val="F3F4F6"/>
           </a:solidFill>
           <a:ln w="12700">
             <a:solidFill>
-              <a:srgbClr val="313A32"/>
+              <a:srgbClr val="CBD5E1"/>
             </a:solidFill>
           </a:ln>
         </p:spPr>
@@ -8750,7 +8750,7 @@
             <a:r>
               <a:rPr sz="900" b="1">
                 <a:solidFill>
-                  <a:srgbClr val="E8FF3F"/>
+                  <a:srgbClr val="8A5A00"/>
                 </a:solidFill>
                 <a:latin typeface="Arial"/>
               </a:rPr>
@@ -8785,11 +8785,11 @@
             <a:r>
               <a:rPr sz="1300" b="1">
                 <a:solidFill>
-                  <a:srgbClr val="F4F6F0"/>
-                </a:solidFill>
-                <a:latin typeface="Arial"/>
-              </a:rPr>
-              <a:t>X402 SERVICE</a:t>
+                  <a:srgbClr val="111827"/>
+                </a:solidFill>
+                <a:latin typeface="Arial"/>
+              </a:rPr>
+              <a:t>SAFE4 402</a:t>
             </a:r>
           </a:p>
         </p:txBody>
@@ -8820,11 +8820,11 @@
             <a:r>
               <a:rPr sz="850" b="0">
                 <a:solidFill>
-                  <a:srgbClr val="99A39A"/>
-                </a:solidFill>
-                <a:latin typeface="Arial"/>
-              </a:rPr>
-              <a:t>Payment required</a:t>
+                  <a:srgbClr val="4B5563"/>
+                </a:solidFill>
+                <a:latin typeface="Arial"/>
+              </a:rPr>
+              <a:t>Scaffolded challenge</a:t>
             </a:r>
           </a:p>
         </p:txBody>
@@ -8845,7 +8845,7 @@
           </a:prstGeom>
           <a:ln w="22860">
             <a:solidFill>
-              <a:srgbClr val="E8FF3F"/>
+              <a:srgbClr val="8A5A00"/>
             </a:solidFill>
           </a:ln>
         </p:spPr>
@@ -8879,11 +8879,11 @@
             <a:avLst/>
           </a:prstGeom>
           <a:solidFill>
-            <a:srgbClr val="111512"/>
+            <a:srgbClr val="F3F4F6"/>
           </a:solidFill>
           <a:ln w="17780">
             <a:solidFill>
-              <a:srgbClr val="E8FF3F"/>
+              <a:srgbClr val="8A5A00"/>
             </a:solidFill>
           </a:ln>
         </p:spPr>
@@ -8935,7 +8935,7 @@
             <a:r>
               <a:rPr sz="900" b="1">
                 <a:solidFill>
-                  <a:srgbClr val="E8FF3F"/>
+                  <a:srgbClr val="8A5A00"/>
                 </a:solidFill>
                 <a:latin typeface="Arial"/>
               </a:rPr>
@@ -8970,7 +8970,7 @@
             <a:r>
               <a:rPr sz="1300" b="1">
                 <a:solidFill>
-                  <a:srgbClr val="F4F6F0"/>
+                  <a:srgbClr val="111827"/>
                 </a:solidFill>
                 <a:latin typeface="Arial"/>
               </a:rPr>
@@ -9005,7 +9005,7 @@
             <a:r>
               <a:rPr sz="850" b="0">
                 <a:solidFill>
-                  <a:srgbClr val="99A39A"/>
+                  <a:srgbClr val="4B5563"/>
                 </a:solidFill>
                 <a:latin typeface="Arial"/>
               </a:rPr>
@@ -9030,7 +9030,7 @@
           </a:prstGeom>
           <a:ln w="22860">
             <a:solidFill>
-              <a:srgbClr val="E8FF3F"/>
+              <a:srgbClr val="8A5A00"/>
             </a:solidFill>
           </a:ln>
         </p:spPr>
@@ -9064,11 +9064,11 @@
             <a:avLst/>
           </a:prstGeom>
           <a:solidFill>
-            <a:srgbClr val="111512"/>
+            <a:srgbClr val="F3F4F6"/>
           </a:solidFill>
           <a:ln w="12700">
             <a:solidFill>
-              <a:srgbClr val="313A32"/>
+              <a:srgbClr val="CBD5E1"/>
             </a:solidFill>
           </a:ln>
         </p:spPr>
@@ -9120,7 +9120,7 @@
             <a:r>
               <a:rPr sz="900" b="1">
                 <a:solidFill>
-                  <a:srgbClr val="E8FF3F"/>
+                  <a:srgbClr val="8A5A00"/>
                 </a:solidFill>
                 <a:latin typeface="Arial"/>
               </a:rPr>
@@ -9155,7 +9155,7 @@
             <a:r>
               <a:rPr sz="1300" b="1">
                 <a:solidFill>
-                  <a:srgbClr val="F4F6F0"/>
+                  <a:srgbClr val="111827"/>
                 </a:solidFill>
                 <a:latin typeface="Arial"/>
               </a:rPr>
@@ -9190,7 +9190,7 @@
             <a:r>
               <a:rPr sz="850" b="0">
                 <a:solidFill>
-                  <a:srgbClr val="99A39A"/>
+                  <a:srgbClr val="4B5563"/>
                 </a:solidFill>
                 <a:latin typeface="Arial"/>
               </a:rPr>
@@ -9215,7 +9215,7 @@
           </a:prstGeom>
           <a:ln w="22860">
             <a:solidFill>
-              <a:srgbClr val="E8FF3F"/>
+              <a:srgbClr val="8A5A00"/>
             </a:solidFill>
           </a:ln>
         </p:spPr>
@@ -9249,11 +9249,11 @@
             <a:avLst/>
           </a:prstGeom>
           <a:solidFill>
-            <a:srgbClr val="111512"/>
+            <a:srgbClr val="F3F4F6"/>
           </a:solidFill>
           <a:ln w="12700">
             <a:solidFill>
-              <a:srgbClr val="313A32"/>
+              <a:srgbClr val="CBD5E1"/>
             </a:solidFill>
           </a:ln>
         </p:spPr>
@@ -9305,7 +9305,7 @@
             <a:r>
               <a:rPr sz="900" b="1">
                 <a:solidFill>
-                  <a:srgbClr val="E8FF3F"/>
+                  <a:srgbClr val="8A5A00"/>
                 </a:solidFill>
                 <a:latin typeface="Arial"/>
               </a:rPr>
@@ -9340,7 +9340,7 @@
             <a:r>
               <a:rPr sz="1300" b="1">
                 <a:solidFill>
-                  <a:srgbClr val="F4F6F0"/>
+                  <a:srgbClr val="111827"/>
                 </a:solidFill>
                 <a:latin typeface="Arial"/>
               </a:rPr>
@@ -9375,7 +9375,7 @@
             <a:r>
               <a:rPr sz="850" b="0">
                 <a:solidFill>
-                  <a:srgbClr val="99A39A"/>
+                  <a:srgbClr val="4B5563"/>
                 </a:solidFill>
                 <a:latin typeface="Arial"/>
               </a:rPr>
@@ -9399,11 +9399,11 @@
             <a:avLst/>
           </a:prstGeom>
           <a:solidFill>
-            <a:srgbClr val="171C18"/>
+            <a:srgbClr val="E5E7EB"/>
           </a:solidFill>
           <a:ln w="12700">
             <a:solidFill>
-              <a:srgbClr val="E8FF3F"/>
+              <a:srgbClr val="8A5A00"/>
             </a:solidFill>
           </a:ln>
         </p:spPr>
@@ -9455,7 +9455,7 @@
             <a:r>
               <a:rPr sz="950" b="1">
                 <a:solidFill>
-                  <a:srgbClr val="70F6A5"/>
+                  <a:srgbClr val="047857"/>
                 </a:solidFill>
                 <a:latin typeface="Arial"/>
               </a:rPr>
@@ -9479,11 +9479,11 @@
             <a:avLst/>
           </a:prstGeom>
           <a:solidFill>
-            <a:srgbClr val="171C18"/>
+            <a:srgbClr val="E5E7EB"/>
           </a:solidFill>
           <a:ln w="12700">
             <a:solidFill>
-              <a:srgbClr val="FF7A68"/>
+              <a:srgbClr val="B91C1C"/>
             </a:solidFill>
           </a:ln>
         </p:spPr>
@@ -9535,7 +9535,7 @@
             <a:r>
               <a:rPr sz="880" b="1">
                 <a:solidFill>
-                  <a:srgbClr val="FF7A68"/>
+                  <a:srgbClr val="B91C1C"/>
                 </a:solidFill>
                 <a:latin typeface="Arial"/>
               </a:rPr>
@@ -9558,7 +9558,7 @@
     <p:bg>
       <p:bgPr>
         <a:solidFill>
-          <a:srgbClr val="090B0A"/>
+          <a:srgbClr val="FFFFFF"/>
         </a:solidFill>
         <a:effectLst/>
       </p:bgPr>
@@ -9726,7 +9726,7 @@
           </a:prstGeom>
           <a:ln w="10160">
             <a:solidFill>
-              <a:srgbClr val="313A32"/>
+              <a:srgbClr val="CBD5E1"/>
             </a:solidFill>
           </a:ln>
         </p:spPr>
@@ -9761,7 +9761,7 @@
           </a:prstGeom>
           <a:ln w="10160">
             <a:solidFill>
-              <a:srgbClr val="313A32"/>
+              <a:srgbClr val="CBD5E1"/>
             </a:solidFill>
           </a:ln>
         </p:spPr>
@@ -9806,7 +9806,7 @@
             <a:r>
               <a:rPr sz="1100" b="1">
                 <a:solidFill>
-                  <a:srgbClr val="E8FF3F"/>
+                  <a:srgbClr val="8A5A00"/>
                 </a:solidFill>
                 <a:latin typeface="Arial"/>
               </a:rPr>
@@ -9841,7 +9841,7 @@
             <a:r>
               <a:rPr sz="900" b="0">
                 <a:solidFill>
-                  <a:srgbClr val="99A39A"/>
+                  <a:srgbClr val="4B5563"/>
                 </a:solidFill>
                 <a:latin typeface="Arial"/>
               </a:rPr>
@@ -9876,7 +9876,7 @@
             <a:r>
               <a:rPr sz="1200" b="1">
                 <a:solidFill>
-                  <a:srgbClr val="F4F6F0"/>
+                  <a:srgbClr val="111827"/>
                 </a:solidFill>
                 <a:latin typeface="Arial"/>
               </a:rPr>
@@ -9946,7 +9946,7 @@
             <a:r>
               <a:rPr sz="1000" b="1">
                 <a:solidFill>
-                  <a:srgbClr val="E8FF3F"/>
+                  <a:srgbClr val="8A5A00"/>
                 </a:solidFill>
                 <a:latin typeface="Arial"/>
               </a:rPr>
@@ -9981,7 +9981,7 @@
             <a:r>
               <a:rPr sz="3100" b="1">
                 <a:solidFill>
-                  <a:srgbClr val="F4F6F0"/>
+                  <a:srgbClr val="111827"/>
                 </a:solidFill>
                 <a:latin typeface="Arial"/>
               </a:rPr>
@@ -10005,11 +10005,11 @@
             <a:avLst/>
           </a:prstGeom>
           <a:solidFill>
-            <a:srgbClr val="111512"/>
+            <a:srgbClr val="F3F4F6"/>
           </a:solidFill>
           <a:ln w="17780">
             <a:solidFill>
-              <a:srgbClr val="70F6A5"/>
+              <a:srgbClr val="047857"/>
             </a:solidFill>
           </a:ln>
         </p:spPr>
@@ -10050,11 +10050,11 @@
             <a:avLst/>
           </a:prstGeom>
           <a:solidFill>
-            <a:srgbClr val="70F6A5"/>
+            <a:srgbClr val="047857"/>
           </a:solidFill>
           <a:ln w="12700">
             <a:solidFill>
-              <a:srgbClr val="70F6A5"/>
+              <a:srgbClr val="047857"/>
             </a:solidFill>
           </a:ln>
         </p:spPr>
@@ -10106,7 +10106,7 @@
             <a:r>
               <a:rPr sz="900" b="1">
                 <a:solidFill>
-                  <a:srgbClr val="090B0A"/>
+                  <a:srgbClr val="FFFFFF"/>
                 </a:solidFill>
                 <a:latin typeface="Arial"/>
               </a:rPr>
@@ -10141,7 +10141,7 @@
             <a:r>
               <a:rPr sz="1800" b="1">
                 <a:solidFill>
-                  <a:srgbClr val="F4F6F0"/>
+                  <a:srgbClr val="111827"/>
                 </a:solidFill>
                 <a:latin typeface="Arial"/>
               </a:rPr>
@@ -10176,7 +10176,7 @@
             <a:r>
               <a:rPr sz="1250" b="0">
                 <a:solidFill>
-                  <a:srgbClr val="99A39A"/>
+                  <a:srgbClr val="4B5563"/>
                 </a:solidFill>
                 <a:latin typeface="Arial"/>
               </a:rPr>
@@ -10211,11 +10211,11 @@
             <a:r>
               <a:rPr sz="919" b="1">
                 <a:solidFill>
-                  <a:srgbClr val="70F6A5"/>
-                </a:solidFill>
-                <a:latin typeface="Arial"/>
-              </a:rPr>
-              <a:t>HISTORICAL REPLAY · NOT BROADCAST BY DEMO</a:t>
+                  <a:srgbClr val="047857"/>
+                </a:solidFill>
+                <a:latin typeface="Arial"/>
+              </a:rPr>
+              <a:t>CIRCLE TX · RPC-VERIFIED REPLAY</a:t>
             </a:r>
           </a:p>
         </p:txBody>
@@ -10235,11 +10235,11 @@
             <a:avLst/>
           </a:prstGeom>
           <a:solidFill>
-            <a:srgbClr val="111512"/>
+            <a:srgbClr val="F3F4F6"/>
           </a:solidFill>
           <a:ln w="17780">
             <a:solidFill>
-              <a:srgbClr val="FF7A68"/>
+              <a:srgbClr val="B91C1C"/>
             </a:solidFill>
           </a:ln>
         </p:spPr>
@@ -10280,11 +10280,11 @@
             <a:avLst/>
           </a:prstGeom>
           <a:solidFill>
-            <a:srgbClr val="FF7A68"/>
+            <a:srgbClr val="B91C1C"/>
           </a:solidFill>
           <a:ln w="12700">
             <a:solidFill>
-              <a:srgbClr val="FF7A68"/>
+              <a:srgbClr val="B91C1C"/>
             </a:solidFill>
           </a:ln>
         </p:spPr>
@@ -10336,7 +10336,7 @@
             <a:r>
               <a:rPr sz="900" b="1">
                 <a:solidFill>
-                  <a:srgbClr val="090B0A"/>
+                  <a:srgbClr val="FFFFFF"/>
                 </a:solidFill>
                 <a:latin typeface="Arial"/>
               </a:rPr>
@@ -10371,7 +10371,7 @@
             <a:r>
               <a:rPr sz="1800" b="1">
                 <a:solidFill>
-                  <a:srgbClr val="F4F6F0"/>
+                  <a:srgbClr val="111827"/>
                 </a:solidFill>
                 <a:latin typeface="Arial"/>
               </a:rPr>
@@ -10406,7 +10406,7 @@
             <a:r>
               <a:rPr sz="1250" b="0">
                 <a:solidFill>
-                  <a:srgbClr val="99A39A"/>
+                  <a:srgbClr val="4B5563"/>
                 </a:solidFill>
                 <a:latin typeface="Arial"/>
               </a:rPr>
@@ -10441,7 +10441,7 @@
             <a:r>
               <a:rPr sz="919" b="1">
                 <a:solidFill>
-                  <a:srgbClr val="FF7A68"/>
+                  <a:srgbClr val="B91C1C"/>
                 </a:solidFill>
                 <a:latin typeface="Arial"/>
               </a:rPr>
@@ -10465,11 +10465,11 @@
             <a:avLst/>
           </a:prstGeom>
           <a:solidFill>
-            <a:srgbClr val="171C18"/>
+            <a:srgbClr val="E5E7EB"/>
           </a:solidFill>
           <a:ln w="12700">
             <a:solidFill>
-              <a:srgbClr val="313A32"/>
+              <a:srgbClr val="CBD5E1"/>
             </a:solidFill>
           </a:ln>
         </p:spPr>
@@ -10519,13 +10519,13 @@
           <a:p>
             <a:pPr algn="l"/>
             <a:r>
-              <a:rPr sz="850" b="1">
-                <a:solidFill>
-                  <a:srgbClr val="E8FF3F"/>
-                </a:solidFill>
-                <a:latin typeface="Arial"/>
-              </a:rPr>
-              <a:t>RPC-VERIFIED HISTORICAL ARC TX</a:t>
+              <a:rPr sz="810" b="1">
+                <a:solidFill>
+                  <a:srgbClr val="8A5A00"/>
+                </a:solidFill>
+                <a:latin typeface="Arial"/>
+              </a:rPr>
+              <a:t>RPC-VERIFIED CIRCLE AGENT WALLET TX</a:t>
             </a:r>
           </a:p>
         </p:txBody>
@@ -10556,7 +10556,7 @@
             <a:r>
               <a:rPr sz="919" b="0">
                 <a:solidFill>
-                  <a:srgbClr val="F4F6F0"/>
+                  <a:srgbClr val="111827"/>
                 </a:solidFill>
                 <a:latin typeface="Consolas"/>
               </a:rPr>
@@ -10579,7 +10579,7 @@
     <p:bg>
       <p:bgPr>
         <a:solidFill>
-          <a:srgbClr val="090B0A"/>
+          <a:srgbClr val="FFFFFF"/>
         </a:solidFill>
         <a:effectLst/>
       </p:bgPr>
@@ -10747,7 +10747,7 @@
           </a:prstGeom>
           <a:ln w="10160">
             <a:solidFill>
-              <a:srgbClr val="313A32"/>
+              <a:srgbClr val="CBD5E1"/>
             </a:solidFill>
           </a:ln>
         </p:spPr>
@@ -10782,7 +10782,7 @@
           </a:prstGeom>
           <a:ln w="10160">
             <a:solidFill>
-              <a:srgbClr val="313A32"/>
+              <a:srgbClr val="CBD5E1"/>
             </a:solidFill>
           </a:ln>
         </p:spPr>
@@ -10827,7 +10827,7 @@
             <a:r>
               <a:rPr sz="1100" b="1">
                 <a:solidFill>
-                  <a:srgbClr val="E8FF3F"/>
+                  <a:srgbClr val="8A5A00"/>
                 </a:solidFill>
                 <a:latin typeface="Arial"/>
               </a:rPr>
@@ -10862,7 +10862,7 @@
             <a:r>
               <a:rPr sz="900" b="0">
                 <a:solidFill>
-                  <a:srgbClr val="99A39A"/>
+                  <a:srgbClr val="4B5563"/>
                 </a:solidFill>
                 <a:latin typeface="Arial"/>
               </a:rPr>
@@ -10897,7 +10897,7 @@
             <a:r>
               <a:rPr sz="1200" b="1">
                 <a:solidFill>
-                  <a:srgbClr val="F4F6F0"/>
+                  <a:srgbClr val="111827"/>
                 </a:solidFill>
                 <a:latin typeface="Arial"/>
               </a:rPr>
@@ -10967,7 +10967,7 @@
             <a:r>
               <a:rPr sz="1000" b="1">
                 <a:solidFill>
-                  <a:srgbClr val="E8FF3F"/>
+                  <a:srgbClr val="8A5A00"/>
                 </a:solidFill>
                 <a:latin typeface="Arial"/>
               </a:rPr>
@@ -11002,7 +11002,7 @@
             <a:r>
               <a:rPr sz="3100" b="1">
                 <a:solidFill>
-                  <a:srgbClr val="F4F6F0"/>
+                  <a:srgbClr val="111827"/>
                 </a:solidFill>
                 <a:latin typeface="Arial"/>
               </a:rPr>
@@ -11026,11 +11026,11 @@
             <a:avLst/>
           </a:prstGeom>
           <a:solidFill>
-            <a:srgbClr val="111512"/>
+            <a:srgbClr val="F3F4F6"/>
           </a:solidFill>
           <a:ln w="12700">
             <a:solidFill>
-              <a:srgbClr val="313A32"/>
+              <a:srgbClr val="CBD5E1"/>
             </a:solidFill>
           </a:ln>
         </p:spPr>
@@ -11082,7 +11082,7 @@
             <a:r>
               <a:rPr sz="900" b="1">
                 <a:solidFill>
-                  <a:srgbClr val="E8FF3F"/>
+                  <a:srgbClr val="8A5A00"/>
                 </a:solidFill>
                 <a:latin typeface="Arial"/>
               </a:rPr>
@@ -11117,11 +11117,11 @@
             <a:r>
               <a:rPr sz="2000" b="1">
                 <a:solidFill>
-                  <a:srgbClr val="F4F6F0"/>
-                </a:solidFill>
-                <a:latin typeface="Arial"/>
-              </a:rPr>
-              <a:t>PAYMENT-NATIVE CHAIN</a:t>
+                  <a:srgbClr val="111827"/>
+                </a:solidFill>
+                <a:latin typeface="Arial"/>
+              </a:rPr>
+              <a:t>TWO EXACT VERIFIER PATHS</a:t>
             </a:r>
           </a:p>
         </p:txBody>
@@ -11152,11 +11152,11 @@
             <a:r>
               <a:rPr sz="1200" b="0">
                 <a:solidFill>
-                  <a:srgbClr val="99A39A"/>
-                </a:solidFill>
-                <a:latin typeface="Arial"/>
-              </a:rPr>
-              <a:t>A purpose-built environment for programmable money. Safe4's exact verifier checks chain, token, calldata, receipt status, and Transfer event.</a:t>
+                  <a:srgbClr val="4B5563"/>
+                </a:solidFill>
+                <a:latin typeface="Arial"/>
+              </a:rPr>
+              <a:t>Direct ERC-20: token + calldata. Agent Wallet: EntryPoint + successful UserOperation + exact transfer event.</a:t>
             </a:r>
           </a:p>
         </p:txBody>
@@ -11176,11 +11176,11 @@
             <a:avLst/>
           </a:prstGeom>
           <a:solidFill>
-            <a:srgbClr val="111512"/>
+            <a:srgbClr val="F3F4F6"/>
           </a:solidFill>
           <a:ln w="12700">
             <a:solidFill>
-              <a:srgbClr val="313A32"/>
+              <a:srgbClr val="CBD5E1"/>
             </a:solidFill>
           </a:ln>
         </p:spPr>
@@ -11232,7 +11232,7 @@
             <a:r>
               <a:rPr sz="900" b="1">
                 <a:solidFill>
-                  <a:srgbClr val="70F6A5"/>
+                  <a:srgbClr val="047857"/>
                 </a:solidFill>
                 <a:latin typeface="Arial"/>
               </a:rPr>
@@ -11267,11 +11267,11 @@
             <a:r>
               <a:rPr sz="2000" b="1">
                 <a:solidFill>
-                  <a:srgbClr val="F4F6F0"/>
-                </a:solidFill>
-                <a:latin typeface="Arial"/>
-              </a:rPr>
-              <a:t>PRECISE SETTLEMENT</a:t>
+                  <a:srgbClr val="111827"/>
+                </a:solidFill>
+                <a:latin typeface="Arial"/>
+              </a:rPr>
+              <a:t>ONE BALANCE, TWO PRECISIONS</a:t>
             </a:r>
           </a:p>
         </p:txBody>
@@ -11302,11 +11302,11 @@
             <a:r>
               <a:rPr sz="1200" b="0">
                 <a:solidFill>
-                  <a:srgbClr val="99A39A"/>
-                </a:solidFill>
-                <a:latin typeface="Arial"/>
-              </a:rPr>
-              <a:t>Six-decimal, dollar-denominated testnet evidence makes the demo amount and token contract unambiguous.</a:t>
+                  <a:srgbClr val="4B5563"/>
+                </a:solidFill>
+                <a:latin typeface="Arial"/>
+              </a:rPr>
+              <a:t>Arc native RPC values use 18 decimals; the ERC-20 interface uses 6. Safe4 normalizes the exact 0.01 amount.</a:t>
             </a:r>
           </a:p>
         </p:txBody>
@@ -11326,11 +11326,11 @@
             <a:avLst/>
           </a:prstGeom>
           <a:solidFill>
-            <a:srgbClr val="111512"/>
+            <a:srgbClr val="F3F4F6"/>
           </a:solidFill>
           <a:ln w="12700">
             <a:solidFill>
-              <a:srgbClr val="313A32"/>
+              <a:srgbClr val="CBD5E1"/>
             </a:solidFill>
           </a:ln>
         </p:spPr>
@@ -11382,7 +11382,7 @@
             <a:r>
               <a:rPr sz="900" b="1">
                 <a:solidFill>
-                  <a:srgbClr val="7FE8FF"/>
+                  <a:srgbClr val="075985"/>
                 </a:solidFill>
                 <a:latin typeface="Arial"/>
               </a:rPr>
@@ -11417,7 +11417,7 @@
             <a:r>
               <a:rPr sz="2000" b="1">
                 <a:solidFill>
-                  <a:srgbClr val="F4F6F0"/>
+                  <a:srgbClr val="111827"/>
                 </a:solidFill>
                 <a:latin typeface="Arial"/>
               </a:rPr>
@@ -11452,7 +11452,7 @@
             <a:r>
               <a:rPr sz="1200" b="0">
                 <a:solidFill>
-                  <a:srgbClr val="99A39A"/>
+                  <a:srgbClr val="4B5563"/>
                 </a:solidFill>
                 <a:latin typeface="Arial"/>
               </a:rPr>
@@ -11475,7 +11475,7 @@
     <p:bg>
       <p:bgPr>
         <a:solidFill>
-          <a:srgbClr val="090B0A"/>
+          <a:srgbClr val="FFFFFF"/>
         </a:solidFill>
         <a:effectLst/>
       </p:bgPr>
@@ -11643,7 +11643,7 @@
           </a:prstGeom>
           <a:ln w="10160">
             <a:solidFill>
-              <a:srgbClr val="313A32"/>
+              <a:srgbClr val="CBD5E1"/>
             </a:solidFill>
           </a:ln>
         </p:spPr>
@@ -11678,7 +11678,7 @@
           </a:prstGeom>
           <a:ln w="10160">
             <a:solidFill>
-              <a:srgbClr val="313A32"/>
+              <a:srgbClr val="CBD5E1"/>
             </a:solidFill>
           </a:ln>
         </p:spPr>
@@ -11723,7 +11723,7 @@
             <a:r>
               <a:rPr sz="1100" b="1">
                 <a:solidFill>
-                  <a:srgbClr val="E8FF3F"/>
+                  <a:srgbClr val="8A5A00"/>
                 </a:solidFill>
                 <a:latin typeface="Arial"/>
               </a:rPr>
@@ -11758,7 +11758,7 @@
             <a:r>
               <a:rPr sz="900" b="0">
                 <a:solidFill>
-                  <a:srgbClr val="99A39A"/>
+                  <a:srgbClr val="4B5563"/>
                 </a:solidFill>
                 <a:latin typeface="Arial"/>
               </a:rPr>
@@ -11793,7 +11793,7 @@
             <a:r>
               <a:rPr sz="1200" b="1">
                 <a:solidFill>
-                  <a:srgbClr val="F4F6F0"/>
+                  <a:srgbClr val="111827"/>
                 </a:solidFill>
                 <a:latin typeface="Arial"/>
               </a:rPr>
@@ -11863,7 +11863,7 @@
             <a:r>
               <a:rPr sz="1000" b="1">
                 <a:solidFill>
-                  <a:srgbClr val="E8FF3F"/>
+                  <a:srgbClr val="8A5A00"/>
                 </a:solidFill>
                 <a:latin typeface="Arial"/>
               </a:rPr>
@@ -11898,7 +11898,7 @@
             <a:r>
               <a:rPr sz="3100" b="1">
                 <a:solidFill>
-                  <a:srgbClr val="F4F6F0"/>
+                  <a:srgbClr val="111827"/>
                 </a:solidFill>
                 <a:latin typeface="Arial"/>
               </a:rPr>
@@ -11922,11 +11922,11 @@
             <a:avLst/>
           </a:prstGeom>
           <a:solidFill>
-            <a:srgbClr val="111512"/>
+            <a:srgbClr val="F3F4F6"/>
           </a:solidFill>
           <a:ln w="12700">
             <a:solidFill>
-              <a:srgbClr val="313A32"/>
+              <a:srgbClr val="CBD5E1"/>
             </a:solidFill>
           </a:ln>
         </p:spPr>
@@ -11978,7 +11978,7 @@
             <a:r>
               <a:rPr sz="900" b="1">
                 <a:solidFill>
-                  <a:srgbClr val="99A39A"/>
+                  <a:srgbClr val="4B5563"/>
                 </a:solidFill>
                 <a:latin typeface="Arial"/>
               </a:rPr>
@@ -12013,7 +12013,7 @@
             <a:r>
               <a:rPr sz="900" b="1">
                 <a:solidFill>
-                  <a:srgbClr val="7FE8FF"/>
+                  <a:srgbClr val="075985"/>
                 </a:solidFill>
                 <a:latin typeface="Arial"/>
               </a:rPr>
@@ -12048,7 +12048,7 @@
             <a:r>
               <a:rPr sz="900" b="1">
                 <a:solidFill>
-                  <a:srgbClr val="E8FF3F"/>
+                  <a:srgbClr val="8A5A00"/>
                 </a:solidFill>
                 <a:latin typeface="Arial"/>
               </a:rPr>
@@ -12073,7 +12073,7 @@
           </a:prstGeom>
           <a:ln w="12700">
             <a:solidFill>
-              <a:srgbClr val="313A32"/>
+              <a:srgbClr val="CBD5E1"/>
             </a:solidFill>
           </a:ln>
         </p:spPr>
@@ -12118,7 +12118,7 @@
             <a:r>
               <a:rPr sz="1200" b="1">
                 <a:solidFill>
-                  <a:srgbClr val="F4F6F0"/>
+                  <a:srgbClr val="111827"/>
                 </a:solidFill>
                 <a:latin typeface="Arial"/>
               </a:rPr>
@@ -12153,7 +12153,7 @@
             <a:r>
               <a:rPr sz="1200" b="0">
                 <a:solidFill>
-                  <a:srgbClr val="99A39A"/>
+                  <a:srgbClr val="4B5563"/>
                 </a:solidFill>
                 <a:latin typeface="Arial"/>
               </a:rPr>
@@ -12188,7 +12188,7 @@
             <a:r>
               <a:rPr sz="1200" b="0">
                 <a:solidFill>
-                  <a:srgbClr val="F4F6F0"/>
+                  <a:srgbClr val="111827"/>
                 </a:solidFill>
                 <a:latin typeface="Arial"/>
               </a:rPr>
@@ -12213,7 +12213,7 @@
           </a:prstGeom>
           <a:ln w="12700">
             <a:solidFill>
-              <a:srgbClr val="313A32"/>
+              <a:srgbClr val="CBD5E1"/>
             </a:solidFill>
           </a:ln>
         </p:spPr>
@@ -12258,7 +12258,7 @@
             <a:r>
               <a:rPr sz="1200" b="1">
                 <a:solidFill>
-                  <a:srgbClr val="F4F6F0"/>
+                  <a:srgbClr val="111827"/>
                 </a:solidFill>
                 <a:latin typeface="Arial"/>
               </a:rPr>
@@ -12293,7 +12293,7 @@
             <a:r>
               <a:rPr sz="1200" b="0">
                 <a:solidFill>
-                  <a:srgbClr val="99A39A"/>
+                  <a:srgbClr val="4B5563"/>
                 </a:solidFill>
                 <a:latin typeface="Arial"/>
               </a:rPr>
@@ -12328,7 +12328,7 @@
             <a:r>
               <a:rPr sz="1200" b="0">
                 <a:solidFill>
-                  <a:srgbClr val="F4F6F0"/>
+                  <a:srgbClr val="111827"/>
                 </a:solidFill>
                 <a:latin typeface="Arial"/>
               </a:rPr>
@@ -12353,7 +12353,7 @@
           </a:prstGeom>
           <a:ln w="12700">
             <a:solidFill>
-              <a:srgbClr val="313A32"/>
+              <a:srgbClr val="CBD5E1"/>
             </a:solidFill>
           </a:ln>
         </p:spPr>
@@ -12398,7 +12398,7 @@
             <a:r>
               <a:rPr sz="1200" b="1">
                 <a:solidFill>
-                  <a:srgbClr val="F4F6F0"/>
+                  <a:srgbClr val="111827"/>
                 </a:solidFill>
                 <a:latin typeface="Arial"/>
               </a:rPr>
@@ -12433,7 +12433,7 @@
             <a:r>
               <a:rPr sz="1200" b="0">
                 <a:solidFill>
-                  <a:srgbClr val="99A39A"/>
+                  <a:srgbClr val="4B5563"/>
                 </a:solidFill>
                 <a:latin typeface="Arial"/>
               </a:rPr>
@@ -12468,7 +12468,7 @@
             <a:r>
               <a:rPr sz="1200" b="0">
                 <a:solidFill>
-                  <a:srgbClr val="E8FF3F"/>
+                  <a:srgbClr val="8A5A00"/>
                 </a:solidFill>
                 <a:latin typeface="Arial"/>
               </a:rPr>
@@ -12503,7 +12503,7 @@
             <a:r>
               <a:rPr sz="900" b="1">
                 <a:solidFill>
-                  <a:srgbClr val="FF7A68"/>
+                  <a:srgbClr val="B91C1C"/>
                 </a:solidFill>
                 <a:latin typeface="Arial"/>
               </a:rPr>
@@ -12538,7 +12538,7 @@
             <a:r>
               <a:rPr sz="1220" b="1">
                 <a:solidFill>
-                  <a:srgbClr val="F4F6F0"/>
+                  <a:srgbClr val="111827"/>
                 </a:solidFill>
                 <a:latin typeface="Arial"/>
               </a:rPr>
@@ -12561,7 +12561,7 @@
     <p:bg>
       <p:bgPr>
         <a:solidFill>
-          <a:srgbClr val="090B0A"/>
+          <a:srgbClr val="FFFFFF"/>
         </a:solidFill>
         <a:effectLst/>
       </p:bgPr>
@@ -12729,7 +12729,7 @@
           </a:prstGeom>
           <a:ln w="10160">
             <a:solidFill>
-              <a:srgbClr val="313A32"/>
+              <a:srgbClr val="CBD5E1"/>
             </a:solidFill>
           </a:ln>
         </p:spPr>
@@ -12764,7 +12764,7 @@
           </a:prstGeom>
           <a:ln w="10160">
             <a:solidFill>
-              <a:srgbClr val="313A32"/>
+              <a:srgbClr val="CBD5E1"/>
             </a:solidFill>
           </a:ln>
         </p:spPr>
@@ -12809,7 +12809,7 @@
             <a:r>
               <a:rPr sz="1100" b="1">
                 <a:solidFill>
-                  <a:srgbClr val="E8FF3F"/>
+                  <a:srgbClr val="8A5A00"/>
                 </a:solidFill>
                 <a:latin typeface="Arial"/>
               </a:rPr>
@@ -12844,7 +12844,7 @@
             <a:r>
               <a:rPr sz="900" b="0">
                 <a:solidFill>
-                  <a:srgbClr val="99A39A"/>
+                  <a:srgbClr val="4B5563"/>
                 </a:solidFill>
                 <a:latin typeface="Arial"/>
               </a:rPr>
@@ -12879,7 +12879,7 @@
             <a:r>
               <a:rPr sz="1200" b="1">
                 <a:solidFill>
-                  <a:srgbClr val="F4F6F0"/>
+                  <a:srgbClr val="111827"/>
                 </a:solidFill>
                 <a:latin typeface="Arial"/>
               </a:rPr>
@@ -12949,7 +12949,7 @@
             <a:r>
               <a:rPr sz="1000" b="1">
                 <a:solidFill>
-                  <a:srgbClr val="E8FF3F"/>
+                  <a:srgbClr val="8A5A00"/>
                 </a:solidFill>
                 <a:latin typeface="Arial"/>
               </a:rPr>
@@ -12984,7 +12984,7 @@
             <a:r>
               <a:rPr sz="3100" b="1">
                 <a:solidFill>
-                  <a:srgbClr val="F4F6F0"/>
+                  <a:srgbClr val="111827"/>
                 </a:solidFill>
                 <a:latin typeface="Arial"/>
               </a:rPr>
@@ -13019,7 +13019,7 @@
             <a:r>
               <a:rPr sz="7800" b="1">
                 <a:solidFill>
-                  <a:srgbClr val="E8FF3F"/>
+                  <a:srgbClr val="8A5A00"/>
                 </a:solidFill>
                 <a:latin typeface="Arial"/>
               </a:rPr>
@@ -13054,7 +13054,7 @@
             <a:r>
               <a:rPr sz="1200" b="1">
                 <a:solidFill>
-                  <a:srgbClr val="F4F6F0"/>
+                  <a:srgbClr val="111827"/>
                 </a:solidFill>
                 <a:latin typeface="Arial"/>
               </a:rPr>
@@ -13089,7 +13089,7 @@
             <a:r>
               <a:rPr sz="1000" b="0">
                 <a:solidFill>
-                  <a:srgbClr val="99A39A"/>
+                  <a:srgbClr val="4B5563"/>
                 </a:solidFill>
                 <a:latin typeface="Arial"/>
               </a:rPr>
@@ -13113,11 +13113,11 @@
             <a:avLst/>
           </a:prstGeom>
           <a:solidFill>
-            <a:srgbClr val="111512"/>
+            <a:srgbClr val="F3F4F6"/>
           </a:solidFill>
           <a:ln w="12700">
             <a:solidFill>
-              <a:srgbClr val="313A32"/>
+              <a:srgbClr val="CBD5E1"/>
             </a:solidFill>
           </a:ln>
         </p:spPr>
@@ -13169,7 +13169,7 @@
             <a:r>
               <a:rPr sz="900" b="1">
                 <a:solidFill>
-                  <a:srgbClr val="E8FF3F"/>
+                  <a:srgbClr val="8A5A00"/>
                 </a:solidFill>
                 <a:latin typeface="Arial"/>
               </a:rPr>
@@ -13204,7 +13204,7 @@
             <a:r>
               <a:rPr sz="2000" b="1">
                 <a:solidFill>
-                  <a:srgbClr val="F4F6F0"/>
+                  <a:srgbClr val="111827"/>
                 </a:solidFill>
                 <a:latin typeface="Arial"/>
               </a:rPr>
@@ -13239,7 +13239,7 @@
             <a:r>
               <a:rPr sz="1200" b="0">
                 <a:solidFill>
-                  <a:srgbClr val="99A39A"/>
+                  <a:srgbClr val="4B5563"/>
                 </a:solidFill>
                 <a:latin typeface="Arial"/>
               </a:rPr>
@@ -13263,11 +13263,11 @@
             <a:avLst/>
           </a:prstGeom>
           <a:solidFill>
-            <a:srgbClr val="111512"/>
+            <a:srgbClr val="F3F4F6"/>
           </a:solidFill>
           <a:ln w="12700">
             <a:solidFill>
-              <a:srgbClr val="313A32"/>
+              <a:srgbClr val="CBD5E1"/>
             </a:solidFill>
           </a:ln>
         </p:spPr>
@@ -13319,7 +13319,7 @@
             <a:r>
               <a:rPr sz="900" b="1">
                 <a:solidFill>
-                  <a:srgbClr val="70F6A5"/>
+                  <a:srgbClr val="047857"/>
                 </a:solidFill>
                 <a:latin typeface="Arial"/>
               </a:rPr>
@@ -13354,7 +13354,7 @@
             <a:r>
               <a:rPr sz="2000" b="1">
                 <a:solidFill>
-                  <a:srgbClr val="F4F6F0"/>
+                  <a:srgbClr val="111827"/>
                 </a:solidFill>
                 <a:latin typeface="Arial"/>
               </a:rPr>
@@ -13389,7 +13389,7 @@
             <a:r>
               <a:rPr sz="1200" b="0">
                 <a:solidFill>
-                  <a:srgbClr val="99A39A"/>
+                  <a:srgbClr val="4B5563"/>
                 </a:solidFill>
                 <a:latin typeface="Arial"/>
               </a:rPr>
@@ -13424,7 +13424,7 @@
             <a:r>
               <a:rPr sz="1100" b="0">
                 <a:solidFill>
-                  <a:srgbClr val="99A39A"/>
+                  <a:srgbClr val="4B5563"/>
                 </a:solidFill>
                 <a:latin typeface="Arial"/>
               </a:rPr>

</xml_diff>

<commit_message>
Add live Arc evidence and edge-case demo
</commit_message>
<xml_diff>
--- a/artifacts/Safe4_Encode_Arc_Deck.pptx
+++ b/artifacts/Safe4_Encode_Arc_Deck.pptx
@@ -4130,7 +4130,7 @@
                 </a:solidFill>
                 <a:latin typeface="Arial"/>
               </a:rPr>
-              <a:t>Public repo: github.com/Safe4AI/safe4-arc-demo · evidence current at 28 Jul 2026</a:t>
+              <a:t>Public repo: github.com/Safe4AI/safe4-arc-demo · evidence current at 5 Aug 2026</a:t>
             </a:r>
           </a:p>
         </p:txBody>
@@ -4350,7 +4350,7 @@
                 </a:solidFill>
                 <a:latin typeface="Arial"/>
               </a:rPr>
-              <a:t>293-test regression gate. Fresh Circle Agent Wallet settlement on Arc. Unattended allow/deny demo. Public repository.</a:t>
+              <a:t>Python 3.13 regression gate. 5 August Circle Agent Wallet settlement on Arc. Unattended allow/deny demo. Public repository.</a:t>
             </a:r>
           </a:p>
         </p:txBody>
@@ -9915,7 +9915,7 @@
                 </a:solidFill>
                 <a:latin typeface="Arial"/>
               </a:rPr>
-              <a:t>Arcscan: testnet.arcscan.app/tx/0x648ef1…7752c · ERC-4337 verifier: scripts/verify_arc_settlement.py</a:t>
+              <a:t>Arcscan: testnet.arcscan.app/tx/0xf9d665…e775d · ERC-4337 verifier: scripts/verify_arc_settlement.py</a:t>
             </a:r>
           </a:p>
         </p:txBody>
@@ -10560,7 +10560,7 @@
                 </a:solidFill>
                 <a:latin typeface="Consolas"/>
               </a:rPr>
-              <a:t>0x648ef14e4da7c6bfecce0017d19280ed51fb12635bea94712de926d9f967752c</a:t>
+              <a:t>0xf9d665cf0eb663e33703826ca599d526718042781860faeec5e7ad089fde775d</a:t>
             </a:r>
           </a:p>
         </p:txBody>

</xml_diff>

<commit_message>
Add x402 decision lab, judge runbook, and reviewed live Arc batch evidence
Publishes the browser-based x402 decision lab and its six predeclared
scenarios, the 90-second judge demo runbook, and the independently reviewed
20260805T123013Z live Arc Testnet batch bundle (three sequential, non-atomic
USDC transfers totaling 0.006 USDC after three local /pay authorizations).

Also adds the edge-case evidence runner and validator, the public-demo audit
script, the Circle marketplace probe, and PowerShell parity for the golden
path and Circle replay demos.

Prepared with scripts/prepare_public_demo.ps1; scripts/audit_public_demo.py
reports 175 files, 0 secrets, 0 forbidden paths. Full suite: 447 passed,
27 subtests passed on Python 3.13.

Co-Authored-By: Claude Opus 5 <noreply@anthropic.com>
</commit_message>
<xml_diff>
--- a/artifacts/Safe4_Encode_Arc_Deck.pptx
+++ b/artifacts/Safe4_Encode_Arc_Deck.pptx
@@ -4130,7 +4130,7 @@
                 </a:solidFill>
                 <a:latin typeface="Arial"/>
               </a:rPr>
-              <a:t>Public repo: github.com/Safe4AI/safe4-arc-demo · evidence current at 28 Jul 2026</a:t>
+              <a:t>Public repo: github.com/Safe4AI/safe4-arc-demo · evidence current at 5 Aug 2026</a:t>
             </a:r>
           </a:p>
         </p:txBody>
@@ -4350,7 +4350,7 @@
                 </a:solidFill>
                 <a:latin typeface="Arial"/>
               </a:rPr>
-              <a:t>293-test regression gate. Fresh Circle Agent Wallet settlement on Arc. Unattended allow/deny demo. Public repository.</a:t>
+              <a:t>Python 3.13 regression gate. 5 August Circle Agent Wallet settlement on Arc. Unattended allow/deny demo. Public repository.</a:t>
             </a:r>
           </a:p>
         </p:txBody>
@@ -9915,7 +9915,7 @@
                 </a:solidFill>
                 <a:latin typeface="Arial"/>
               </a:rPr>
-              <a:t>Arcscan: testnet.arcscan.app/tx/0x648ef1…7752c · ERC-4337 verifier: scripts/verify_arc_settlement.py</a:t>
+              <a:t>Arcscan: testnet.arcscan.app/tx/0xf9d665…e775d · ERC-4337 verifier: scripts/verify_arc_settlement.py</a:t>
             </a:r>
           </a:p>
         </p:txBody>
@@ -10560,7 +10560,7 @@
                 </a:solidFill>
                 <a:latin typeface="Consolas"/>
               </a:rPr>
-              <a:t>0x648ef14e4da7c6bfecce0017d19280ed51fb12635bea94712de926d9f967752c</a:t>
+              <a:t>0xf9d665cf0eb663e33703826ca599d526718042781860faeec5e7ad089fde775d</a:t>
             </a:r>
           </a:p>
         </p:txBody>

</xml_diff>